<commit_message>
Completa sección, grupo y docente en la carátula y la portada
</commit_message>
<xml_diff>
--- a/docs/PixelLang_Presentacion.pptx
+++ b/docs/PixelLang_Presentacion.pptx
@@ -121,52 +121,52 @@
   <p:extLst>
     <p:ext uri="{521415D9-36F7-43E2-AB2F-B90AF26B5E84}">
       <p14:sectionLst xmlns:p14="http://schemas.microsoft.com/office/powerpoint/2010/main">
-        <p14:section name="Portada" id="{21b2ea06-b207-fc33-ad1a-c2ef26cd21cf}">
+        <p14:section name="Portada" id="{c92690c8-63e0-d8f8-dc75-037e943bdc22}">
           <p14:sldIdLst>
             <p14:sldId id="256"/>
           </p14:sldIdLst>
         </p14:section>
-        <p14:section name="Problemática y motivación" id="{e9ed3539-d497-2c34-9264-239ec3ee06b6}">
+        <p14:section name="Problemática y motivación" id="{ea7ddb2b-4baa-5625-6953-dc4812db4153}">
           <p14:sldIdLst>
             <p14:sldId id="257"/>
             <p14:sldId id="258"/>
             <p14:sldId id="259"/>
           </p14:sldIdLst>
         </p14:section>
-        <p14:section name="Objetivos" id="{8344acb9-9bde-d387-7b01-3ef11246850e}">
+        <p14:section name="Objetivos" id="{28c09e08-3376-4cfd-f584-35982f900579}">
           <p14:sldIdLst>
             <p14:sldId id="260"/>
           </p14:sldIdLst>
         </p14:section>
-        <p14:section name="Construcciones del lenguaje" id="{a7a258e7-7b9b-de6d-1717-0d552cd79eb4}">
+        <p14:section name="Construcciones del lenguaje" id="{9a2a2e1b-8e64-9f7e-c388-261dabd1bad7}">
           <p14:sldIdLst>
             <p14:sldId id="261"/>
             <p14:sldId id="262"/>
           </p14:sldIdLst>
         </p14:section>
-        <p14:section name="Analizador léxico" id="{4ab67c6a-4d12-8f22-71c1-665e735e78f4}">
+        <p14:section name="Analizador léxico" id="{54b87acd-d21c-aaf0-9311-c101847723e8}">
           <p14:sldIdLst>
             <p14:sldId id="263"/>
           </p14:sldIdLst>
         </p14:section>
-        <p14:section name="Analizador sintáctico" id="{0c37d738-fb31-e05d-ebc4-bbba3197c3d9}">
+        <p14:section name="Analizador sintáctico" id="{3aeb1bdb-81f3-325e-b3de-8b138ceebfd2}">
           <p14:sldIdLst>
             <p14:sldId id="264"/>
             <p14:sldId id="265"/>
           </p14:sldIdLst>
         </p14:section>
-        <p14:section name="Analizador semántico" id="{8c597771-07ad-0d77-a28c-59508f62ff15}">
+        <p14:section name="Analizador semántico" id="{b9d38caa-cdef-1068-4978-17e22f668ad8}">
           <p14:sldIdLst>
             <p14:sldId id="266"/>
             <p14:sldId id="267"/>
           </p14:sldIdLst>
         </p14:section>
-        <p14:section name="Repositorio y pruebas" id="{a772a76f-f0a0-886a-4fdb-88b8fc167b71}">
+        <p14:section name="Repositorio y pruebas" id="{b4e0f673-8011-c2e1-54ee-89eb8ddc695e}">
           <p14:sldIdLst>
             <p14:sldId id="268"/>
           </p14:sldIdLst>
         </p14:section>
-        <p14:section name="Cierre" id="{762e907b-9eb3-4302-d35e-2fb95ee0cae4}">
+        <p14:section name="Cierre" id="{be854c9e-7bc7-7554-23d5-7d45f3ef2c87}">
           <p14:sldIdLst>
             <p14:sldId id="269"/>
             <p14:sldId id="270"/>
@@ -3108,7 +3108,7 @@
                   <a:schemeClr val="accent6"/>
                 </a:solidFill>
               </a:rPr>
-              <a:t>Sección: ______     Docente: ____________________     Grupo: ____</a:t>
+              <a:t>Sección 13962  |  Grupo 5  |  Docente: Marco Antonio Sobrevilla Cabezudo</a:t>
             </a:r>
             <a:endParaRPr lang="es-PE" sz="1600" dirty="0"/>
           </a:p>

</xml_diff>

<commit_message>
Actualiza el informe y la presentación con el visitor y la tabla de símbolos
</commit_message>
<xml_diff>
--- a/docs/PixelLang_Presentacion.pptx
+++ b/docs/PixelLang_Presentacion.pptx
@@ -121,52 +121,52 @@
   <p:extLst>
     <p:ext uri="{521415D9-36F7-43E2-AB2F-B90AF26B5E84}">
       <p14:sectionLst xmlns:p14="http://schemas.microsoft.com/office/powerpoint/2010/main">
-        <p14:section name="Portada" id="{c92690c8-63e0-d8f8-dc75-037e943bdc22}">
+        <p14:section name="Portada" id="{b8469a1e-bdc8-8c29-432b-055088cfa73d}">
           <p14:sldIdLst>
             <p14:sldId id="256"/>
           </p14:sldIdLst>
         </p14:section>
-        <p14:section name="Problemática y motivación" id="{ea7ddb2b-4baa-5625-6953-dc4812db4153}">
+        <p14:section name="Problemática y motivación" id="{b51b7e45-08a1-4b5f-bc9d-427238f07f41}">
           <p14:sldIdLst>
             <p14:sldId id="257"/>
             <p14:sldId id="258"/>
             <p14:sldId id="259"/>
           </p14:sldIdLst>
         </p14:section>
-        <p14:section name="Objetivos" id="{28c09e08-3376-4cfd-f584-35982f900579}">
+        <p14:section name="Objetivos" id="{e072904c-48a3-00f1-f771-3472bb471760}">
           <p14:sldIdLst>
             <p14:sldId id="260"/>
           </p14:sldIdLst>
         </p14:section>
-        <p14:section name="Construcciones del lenguaje" id="{9a2a2e1b-8e64-9f7e-c388-261dabd1bad7}">
+        <p14:section name="Construcciones del lenguaje" id="{8958bad3-e777-bbfc-64fa-74b1fb80d5ed}">
           <p14:sldIdLst>
             <p14:sldId id="261"/>
             <p14:sldId id="262"/>
           </p14:sldIdLst>
         </p14:section>
-        <p14:section name="Analizador léxico" id="{54b87acd-d21c-aaf0-9311-c101847723e8}">
+        <p14:section name="Analizador léxico" id="{d96a4c44-ea07-d7cc-4352-7acc9241de22}">
           <p14:sldIdLst>
             <p14:sldId id="263"/>
           </p14:sldIdLst>
         </p14:section>
-        <p14:section name="Analizador sintáctico" id="{3aeb1bdb-81f3-325e-b3de-8b138ceebfd2}">
+        <p14:section name="Analizador sintáctico" id="{e351ec2f-f71c-657f-7230-2772ea7c5eae}">
           <p14:sldIdLst>
             <p14:sldId id="264"/>
             <p14:sldId id="265"/>
           </p14:sldIdLst>
         </p14:section>
-        <p14:section name="Analizador semántico" id="{b9d38caa-cdef-1068-4978-17e22f668ad8}">
+        <p14:section name="Analizador semántico" id="{c33f6ee5-8794-4ff8-2c16-f45058276b68}">
           <p14:sldIdLst>
             <p14:sldId id="266"/>
             <p14:sldId id="267"/>
           </p14:sldIdLst>
         </p14:section>
-        <p14:section name="Repositorio y pruebas" id="{b4e0f673-8011-c2e1-54ee-89eb8ddc695e}">
+        <p14:section name="Repositorio y pruebas" id="{136ecfc6-dc63-e438-7d8a-d7144bb8aa0d}">
           <p14:sldIdLst>
             <p14:sldId id="268"/>
           </p14:sldIdLst>
         </p14:section>
-        <p14:section name="Cierre" id="{be854c9e-7bc7-7554-23d5-7d45f3ef2c87}">
+        <p14:section name="Cierre" id="{fe6fcd4f-c343-2d53-a623-06093c5fd67e}">
           <p14:sldIdLst>
             <p14:sldId id="269"/>
             <p14:sldId id="270"/>
@@ -757,10 +757,10 @@
           <a:p>
             <a:r>
               <a:rPr lang="es-PE" dirty="0"/>
-              <a:t>Mateo (aprox. 55 s)
-Gracias, Antony. Que un programa sea sintácticamente correcto no garantiza que su autómata tenga sentido; de eso se encarga el analizador semántico. Recorre el árbol sintáctico y construye una tabla de símbolos por personaje.
-Tomemos este programa. Su tabla guarda el atributo vida con su tipo, los tres eventos y los dos estados declarados, Reposo, que es el inicial, y Saltando. Fíjense que la tabla nos da las partes del autómata: los eventos son Σ, los estados son Q y el inicial es q0; como no hay estados finales, F es vacío.
-Con esa tabla el analizador revisa cada transición. Este programa pasa el análisis léxico y el sintáctico, pero tiene dos errores.</a:t>
+              <a:t>Mateo (aprox. 1 min)
+Gracias, Antony. Que un programa sea sintácticamente correcto no garantiza que su autómata tenga sentido; de eso se encarga el analizador semántico. Como en los laboratorios 4 y 5, es un visitor que recorre el árbol sintáctico que genera ANTLR: al visitar una declaración inserta el símbolo en la tabla, y al visitar un uso lo busca.
+La tabla tiene dos ámbitos: el global, con los personajes, y el de cada personaje. A la derecha está el ámbito de este Caballero, tal como lo imprime la opción --tabla: el atributo vida con su tipo, los tres eventos y los dos estados, con Reposo marcado como inicial. Fíjense que la tabla nos da las partes del autómata: los eventos son Σ, los estados son Q y el inicial es q0; como no hay estados finales, F es vacío.
+Este programa pasa el análisis léxico y el sintáctico, pero tiene dos errores.</a:t>
             </a:r>
             <a:endParaRPr lang="es-PE" dirty="0"/>
           </a:p>
@@ -852,7 +852,7 @@
 Son los dos errores que describimos en el informe, y los dos salen de la definición de autómata.
 E01: en la línea 10, Saltando va hacia Volando, que no está en la tabla. La función de transición solo puede llevar a estados de Q.
 E03: en Reposo hay dos transiciones con saltar y ninguna tiene guarda, así que la segunda nunca se toma. Para cada estado y evento, δ tiene un único destino.
-El compilador indica el código del error, la línea y el motivo. Además de estos dos, verifica otros ocho, como los estados inalcanzables o los eventos no declarados; están descritos en el Apéndice C.</a:t>
+Como pide la clase, cada error indica su código, su línea y su columna, y el análisis no se detiene en el primero: reporta todos juntos. Además de estos dos, el compilador verifica otros ocho, como los estados inalcanzables o los eventos no declarados; están en el Apéndice C.</a:t>
             </a:r>
             <a:endParaRPr lang="es-PE" dirty="0"/>
           </a:p>
@@ -941,7 +941,7 @@
             <a:r>
               <a:rPr lang="es-PE" dirty="0"/>
               <a:t>Mateo (aprox. 55 s)
-Todo está en el repositorio de GitHub. La gramática combinada, PixelLang.g4, contiene el léxico y la sintaxis, y a partir de ella ANTLR4 genera el lexer y el parser. El driver, main.py, ejecuta las etapas en orden: con --tokens muestra los tokens y con --arbol, el árbol sintáctico.
+Todo está en el repositorio de GitHub. La gramática combinada, PixelLang.g4, contiene el léxico y la sintaxis, y a partir de ella ANTLR4 genera el lexer y el parser. El driver, main.py, ejecuta las etapas en orden: con --tokens muestra los tokens, con --arbol el árbol sintáctico y con --tabla, la tabla de símbolos.
 Probamos cada analizador con entradas válidas e inválidas. Para el léxico, una entrada válida y cinco con caracteres o lexemas que no pertenecen al lenguaje. Para el sintáctico, los 35 ejemplos, que se aceptan, y seis programas con errores, que se rechazan. Y para el semántico, un programa por cada error. Están en el Apéndice D. El avance lo organizamos en GitHub, con un hito por entrega e issues por tarea.</a:t>
             </a:r>
             <a:endParaRPr lang="es-PE" dirty="0"/>
@@ -1128,8 +1128,9 @@
 2. Generar el parser con Ctrl+Shift+B.
 3. Ejecutar main.py con --tokens y mostrar los tokens de las primeras líneas.
 4. Ejecutar con --arbol y mostrar una parte del árbol.
-5. Cambiar una transición para que vaya a Volando y mostrar el error E01.
-6. Ejecutar pruebas/correr_pruebas.py.</a:t>
+5. Ejecutar con --tabla y mostrar la tabla de símbolos.
+6. Cambiar una transición para que vaya a Volando y mostrar el error E01 con su línea y columna.
+7. Ejecutar pruebas/correr_pruebas.py.</a:t>
             </a:r>
             <a:endParaRPr lang="es-PE" dirty="0"/>
           </a:p>
@@ -7665,7 +7666,7 @@
                   <a:schemeClr val="tx1"/>
                 </a:solidFill>
               </a:rPr>
-              <a:t>Una tabla de símbolos por personaje</a:t>
+              <a:t>Un visitor construye la tabla de símbolos</a:t>
             </a:r>
             <a:endParaRPr lang="es-PE" sz="2800" dirty="0"/>
           </a:p>
@@ -8497,7 +8498,7 @@
         <p:spPr>
           <a:xfrm>
             <a:off x="5989320" y="1536192"/>
-            <a:ext cx="4572000" cy="274320"/>
+            <a:ext cx="5486400" cy="274320"/>
           </a:xfrm>
           <a:prstGeom prst="rect">
             <a:avLst/>
@@ -8518,7 +8519,7 @@
                   <a:schemeClr val="accent5"/>
                 </a:solidFill>
               </a:rPr>
-              <a:t>Tabla de símbolos de Caballero</a:t>
+              <a:t>Ámbito de Caballero (salida de --tabla)</a:t>
             </a:r>
             <a:endParaRPr lang="es-PE" sz="1200" dirty="0"/>
           </a:p>
@@ -11231,7 +11232,7 @@
                 <a:ea typeface="Consolas" pitchFamily="34" charset="-122"/>
                 <a:cs typeface="Consolas" pitchFamily="34" charset="-120"/>
               </a:rPr>
-              <a:t>Error semántico E01 en la línea 10:</a:t>
+              <a:t>Error semántico E01 en la línea 10, columna 25:</a:t>
             </a:r>
             <a:endParaRPr lang="es-PE" sz="1200" dirty="0"/>
           </a:p>
@@ -11760,7 +11761,7 @@
                 <a:ea typeface="Consolas" pitchFamily="34" charset="-122"/>
                 <a:cs typeface="Consolas" pitchFamily="34" charset="-120"/>
               </a:rPr>
-              <a:t>Error semántico E03 en la línea 6:</a:t>
+              <a:t>Error semántico E03 en la línea 6, columna 8:</a:t>
             </a:r>
             <a:endParaRPr lang="es-PE" sz="1200" dirty="0"/>
           </a:p>
@@ -12229,7 +12230,7 @@
                 <a:ea typeface="Consolas" pitchFamily="34" charset="-122"/>
                 <a:cs typeface="Consolas" pitchFamily="34" charset="-120"/>
               </a:rPr>
-              <a:t>tabla de símbolos, E01 a E10</a:t>
+              <a:t>visitor: tabla de símbolos, E01 a E10</a:t>
             </a:r>
             <a:endParaRPr lang="es-PE" sz="1250" dirty="0"/>
           </a:p>
@@ -12433,7 +12434,7 @@
                 <a:ea typeface="Consolas" pitchFamily="34" charset="-122"/>
                 <a:cs typeface="Consolas" pitchFamily="34" charset="-120"/>
               </a:rPr>
-              <a:t>       --tokens --arbol</a:t>
+              <a:t>       --tokens --arbol --tabla</a:t>
             </a:r>
             <a:endParaRPr lang="es-PE" sz="1250" dirty="0"/>
           </a:p>

</xml_diff>

<commit_message>
Agrega el enlace del video en el informe, la presentación y el README
El Anexo B del informe y la última diapositiva tienen el enlace al video de demostración en Google Drive, y en los dos se abre con un clic. El README tiene una tabla con el informe, la presentación y el video.
</commit_message>
<xml_diff>
--- a/docs/PixelLang_Presentacion.pptx
+++ b/docs/PixelLang_Presentacion.pptx
@@ -121,52 +121,52 @@
   <p:extLst>
     <p:ext uri="{521415D9-36F7-43E2-AB2F-B90AF26B5E84}">
       <p14:sectionLst xmlns:p14="http://schemas.microsoft.com/office/powerpoint/2010/main">
-        <p14:section name="Portada" id="{b8469a1e-bdc8-8c29-432b-055088cfa73d}">
+        <p14:section name="Portada" id="{63ab8320-d297-0825-308c-f9b0619a6d5f}">
           <p14:sldIdLst>
             <p14:sldId id="256"/>
           </p14:sldIdLst>
         </p14:section>
-        <p14:section name="Problemática y motivación" id="{b51b7e45-08a1-4b5f-bc9d-427238f07f41}">
+        <p14:section name="Problemática y motivación" id="{12068659-8050-6cb2-7ad1-c39028b84117}">
           <p14:sldIdLst>
             <p14:sldId id="257"/>
             <p14:sldId id="258"/>
             <p14:sldId id="259"/>
           </p14:sldIdLst>
         </p14:section>
-        <p14:section name="Objetivos" id="{e072904c-48a3-00f1-f771-3472bb471760}">
+        <p14:section name="Objetivos" id="{66c5cd15-c91a-21eb-8f78-a6ba634c5ac2}">
           <p14:sldIdLst>
             <p14:sldId id="260"/>
           </p14:sldIdLst>
         </p14:section>
-        <p14:section name="Construcciones del lenguaje" id="{8958bad3-e777-bbfc-64fa-74b1fb80d5ed}">
+        <p14:section name="Construcciones del lenguaje" id="{1954f100-2161-bbd5-241c-dbc62b71f305}">
           <p14:sldIdLst>
             <p14:sldId id="261"/>
             <p14:sldId id="262"/>
           </p14:sldIdLst>
         </p14:section>
-        <p14:section name="Analizador léxico" id="{d96a4c44-ea07-d7cc-4352-7acc9241de22}">
+        <p14:section name="Analizador léxico" id="{ca7205d3-7f6f-8d02-9cdc-998ffee0b26a}">
           <p14:sldIdLst>
             <p14:sldId id="263"/>
           </p14:sldIdLst>
         </p14:section>
-        <p14:section name="Analizador sintáctico" id="{e351ec2f-f71c-657f-7230-2772ea7c5eae}">
+        <p14:section name="Analizador sintáctico" id="{1bc80d97-5387-cc32-bbe1-21f2826758a4}">
           <p14:sldIdLst>
             <p14:sldId id="264"/>
             <p14:sldId id="265"/>
           </p14:sldIdLst>
         </p14:section>
-        <p14:section name="Analizador semántico" id="{c33f6ee5-8794-4ff8-2c16-f45058276b68}">
+        <p14:section name="Analizador semántico" id="{fee47412-06b8-6241-ef67-340828373254}">
           <p14:sldIdLst>
             <p14:sldId id="266"/>
             <p14:sldId id="267"/>
           </p14:sldIdLst>
         </p14:section>
-        <p14:section name="Repositorio y pruebas" id="{136ecfc6-dc63-e438-7d8a-d7144bb8aa0d}">
+        <p14:section name="Repositorio y pruebas" id="{6396c896-5024-c036-e8ba-0c4ba889fc77}">
           <p14:sldIdLst>
             <p14:sldId id="268"/>
           </p14:sldIdLst>
         </p14:section>
-        <p14:section name="Cierre" id="{fe6fcd4f-c343-2d53-a623-06093c5fd67e}">
+        <p14:section name="Cierre" id="{d4f3e34d-74c3-a97c-675b-294f1127fd08}">
           <p14:sldIdLst>
             <p14:sldId id="269"/>
             <p14:sldId id="270"/>
@@ -1122,15 +1122,7 @@
               <a:t>Mateo (aprox. 10 s, más el video)
 Para terminar, les mostramos el compilador funcionando.
 [Reproducir el video. Al terminar: "Eso es PixelLang. Muchas gracias, quedamos atentos a sus preguntas."]
-Para insertar el video: Insertar &gt; Vídeo &gt; Este dispositivo, y ajustarlo al recuadro.
-Recorrido sugerido para el video (5 minutos como máximo):
-1. Abrir ejemplos/caballero.pxl en Visual Studio Code.
-2. Generar el parser con Ctrl+Shift+B.
-3. Ejecutar main.py con --tokens y mostrar los tokens de las primeras líneas.
-4. Ejecutar con --arbol y mostrar una parte del árbol.
-5. Ejecutar con --tabla y mostrar la tabla de símbolos.
-6. Cambiar una transición para que vaya a Volando y mostrar el error E01 con su línea y columna.
-7. Ejecutar pruebas/correr_pruebas.py.</a:t>
+El video está en Google Drive: https://drive.google.com/file/d/1asrzQjXH87vR6JPZDanqDFVFOEntwdZ8/view?usp=sharing. Durante la presentación se abre con un clic en el recuadro o en el enlace de abajo. Para que se reproduzca sin internet, se puede insertar con Insertar &gt; Vídeo &gt; Este dispositivo y ajustarlo al recuadro.</a:t>
             </a:r>
             <a:endParaRPr lang="es-PE" dirty="0"/>
           </a:p>
@@ -13708,7 +13700,9 @@
       </p:sp>
       <p:sp>
         <p:nvSpPr>
-          <p:cNvPr id="4" name="Marco del video"/>
+          <p:cNvPr id="4" name="Marco del video">
+            <a:hlinkClick r:id="rId1" tooltip="Ver el video en Google Drive"/>
+          </p:cNvPr>
           <p:cNvSpPr/>
           <p:nvPr/>
         </p:nvSpPr>
@@ -13765,7 +13759,7 @@
           <p:nvPr/>
         </p:nvPicPr>
         <p:blipFill>
-          <a:blip r:embed="rId1"/>
+          <a:blip r:embed="rId2"/>
           <a:stretch>
             <a:fillRect/>
           </a:stretch>
@@ -13805,14 +13799,29 @@
               <a:buNone/>
             </a:pPr>
             <a:r>
-              <a:rPr lang="es-PE" sz="1300" dirty="0">
+              <a:rPr lang="es-PE" sz="1200" dirty="0">
                 <a:solidFill>
                   <a:schemeClr val="accent6"/>
                 </a:solidFill>
               </a:rPr>
-              <a:t>Video de demostración (5 minutos como máximo)</a:t>
-            </a:r>
-            <a:endParaRPr lang="es-PE" sz="1300" dirty="0"/>
+              <a:t>Video de demostración: </a:t>
+            </a:r>
+            <a:r>
+              <a:rPr lang="es-PE" sz="1200" u="sng" dirty="0">
+                <a:solidFill>
+                  <a:schemeClr val="accent6"/>
+                </a:solidFill>
+                <a:hlinkClick r:id="rId3" invalidUrl="" action="" tgtFrame="" tooltip="Ver el video en Google Drive" history="1" highlightClick="0" endSnd="0">
+                  <a:extLst>
+                    <a:ext uri="{A12FA001-AC4F-418D-AE19-62706E023703}">
+                      <ahyp:hlinkClr xmlns:ahyp="http://schemas.microsoft.com/office/drawing/2018/hyperlinkcolor" val="tx"/>
+                    </a:ext>
+                  </a:extLst>
+                </a:hlinkClick>
+              </a:rPr>
+              <a:t>https://drive.google.com/file/d/1asrzQjXH87vR6JPZDanqDFVFOEntwdZ8/view?usp=sharing</a:t>
+            </a:r>
+            <a:endParaRPr lang="es-PE" sz="1200" dirty="0"/>
           </a:p>
         </p:txBody>
       </p:sp>

</xml_diff>

<commit_message>
Mejora la problemática: importancia, proceso actual y motivación
El informe y la presentación responden las preguntas del enunciado: por qué el problema es importante (un error en la máquina de estados llega al jugador y el compilador del juego no lo detecta), qué existe hoy y por qué revisarlo es un proceso largo (30 combinaciones de estado y evento en un personaje con 5 estados y 6 eventos, probadas a mano en cada cambio). Se agrega la motivación de aplicar los temas del curso. Las notas de Diego siguen ese orden.
</commit_message>
<xml_diff>
--- a/docs/PixelLang_Presentacion.pptx
+++ b/docs/PixelLang_Presentacion.pptx
@@ -121,52 +121,52 @@
   <p:extLst>
     <p:ext uri="{521415D9-36F7-43E2-AB2F-B90AF26B5E84}">
       <p14:sectionLst xmlns:p14="http://schemas.microsoft.com/office/powerpoint/2010/main">
-        <p14:section name="Portada" id="{63ab8320-d297-0825-308c-f9b0619a6d5f}">
+        <p14:section name="Portada" id="{d839d646-af85-8d7f-6229-e31e11e8eb68}">
           <p14:sldIdLst>
             <p14:sldId id="256"/>
           </p14:sldIdLst>
         </p14:section>
-        <p14:section name="Problemática y motivación" id="{12068659-8050-6cb2-7ad1-c39028b84117}">
+        <p14:section name="Problemática y motivación" id="{6ba6a23c-553e-c975-2319-7e82000be4c0}">
           <p14:sldIdLst>
             <p14:sldId id="257"/>
             <p14:sldId id="258"/>
             <p14:sldId id="259"/>
           </p14:sldIdLst>
         </p14:section>
-        <p14:section name="Objetivos" id="{66c5cd15-c91a-21eb-8f78-a6ba634c5ac2}">
+        <p14:section name="Objetivos" id="{a2b809c6-d508-9d14-b3bf-8102c2f115d2}">
           <p14:sldIdLst>
             <p14:sldId id="260"/>
           </p14:sldIdLst>
         </p14:section>
-        <p14:section name="Construcciones del lenguaje" id="{1954f100-2161-bbd5-241c-dbc62b71f305}">
+        <p14:section name="Construcciones del lenguaje" id="{fc2e7bb4-2df3-7e09-7c55-2fb5a65f7ff7}">
           <p14:sldIdLst>
             <p14:sldId id="261"/>
             <p14:sldId id="262"/>
           </p14:sldIdLst>
         </p14:section>
-        <p14:section name="Analizador léxico" id="{ca7205d3-7f6f-8d02-9cdc-998ffee0b26a}">
+        <p14:section name="Analizador léxico" id="{3ba4e23b-0c1a-9bf8-b467-8b67e57ce9ec}">
           <p14:sldIdLst>
             <p14:sldId id="263"/>
           </p14:sldIdLst>
         </p14:section>
-        <p14:section name="Analizador sintáctico" id="{1bc80d97-5387-cc32-bbe1-21f2826758a4}">
+        <p14:section name="Analizador sintáctico" id="{41785f60-74cb-1cdd-e784-496d2fdaa346}">
           <p14:sldIdLst>
             <p14:sldId id="264"/>
             <p14:sldId id="265"/>
           </p14:sldIdLst>
         </p14:section>
-        <p14:section name="Analizador semántico" id="{fee47412-06b8-6241-ef67-340828373254}">
+        <p14:section name="Analizador semántico" id="{3b52b793-6926-a475-42af-5860c6222d44}">
           <p14:sldIdLst>
             <p14:sldId id="266"/>
             <p14:sldId id="267"/>
           </p14:sldIdLst>
         </p14:section>
-        <p14:section name="Repositorio y pruebas" id="{6396c896-5024-c036-e8ba-0c4ba889fc77}">
+        <p14:section name="Repositorio y pruebas" id="{fcee7fce-6978-ba67-25c3-34a9b068c60e}">
           <p14:sldIdLst>
             <p14:sldId id="268"/>
           </p14:sldIdLst>
         </p14:section>
-        <p14:section name="Cierre" id="{d4f3e34d-74c3-a97c-675b-294f1127fd08}">
+        <p14:section name="Cierre" id="{0c6e6fc4-83d5-1d5e-bc65-ef8c87a6d9b3}">
           <p14:sldIdLst>
             <p14:sldId id="269"/>
             <p14:sldId id="270"/>
@@ -578,7 +578,7 @@
               <a:rPr lang="es-PE" dirty="0"/>
               <a:t>Diego (aprox. 30 s)
 Buenos días, profesor y compañeros. Somos Diego, David, Antony y Mateo, y les presentamos PixelLang, el lenguaje que diseñamos para el trabajo parcial.
-PixelLang sirve para describir cómo se comporta un personaje de un videojuego 2D: en qué estados puede estar y qué lo hace pasar de uno a otro. Yo empiezo con la problemática; luego David presenta los objetivos y las construcciones del lenguaje, Antony el análisis léxico y el sintáctico, y Mateo el análisis semántico y la demostración.</a:t>
+PixelLang sirve para describir cómo se comporta un personaje de un videojuego 2D: en qué estados puede estar y qué lo hace pasar de uno a otro. Yo presento la problemática: cuál es el problema, por qué es importante y qué existe hoy. Luego David presenta los objetivos y las construcciones del lenguaje, Antony el análisis léxico y el sintáctico, y Mateo el análisis semántico y la demostración.</a:t>
             </a:r>
             <a:endParaRPr lang="es-PE" dirty="0"/>
           </a:p>
@@ -1211,9 +1211,9 @@
             <a:r>
               <a:rPr lang="es-PE" dirty="0"/>
               <a:t>Diego (aprox. 55 s)
-En un juego 2D, el comportamiento de un personaje se describe con una máquina de estados finitos: el personaje está en reposo, saltando, atacando o aturdido, y cambia de estado cuando ocurre un evento, como pulsar un botón o recibir un golpe. Así lo explica Nystrom en Game Programming Patterns.
-El problema es que esa máquina casi nunca se escribe como tal. En el código queda como lo que ven a la izquierda: condicionales que revisan banderas. Nada impide que atacando y aturdido queden activas a la vez, y para saber qué estados existen hay que leer todo el bucle.
-En los editores visuales, como el de Unity, los estados sí se dibujan como nodos, pero las condiciones de cada transición quedan en paneles separados.</a:t>
+Empiezo por el problema. En un juego 2D, el comportamiento de un personaje se describe con una máquina de estados finitos: el personaje está en reposo, saltando, atacando o aturdido, y cambia de estado cuando ocurre un evento, como pulsar un botón o recibir un golpe. Así lo explica Nystrom en Game Programming Patterns.
+Sin embargo, esa máquina casi nunca se escribe como tal. En el código queda como lo que ven a la izquierda: condicionales que revisan banderas. Nada impide que atacando y aturdido queden activas a la vez, y para saber qué estados existen hay que leer todo el bucle.
+En los editores visuales, como el de Unity, los estados sí se dibujan como nodos, pero las condiciones de cada transición quedan en paneles separados. La máquina existe en el diseño, pero no queda escrita en ninguna parte.</a:t>
             </a:r>
             <a:endParaRPr lang="es-PE" dirty="0"/>
           </a:p>
@@ -1301,9 +1301,10 @@
           <a:p>
             <a:r>
               <a:rPr lang="es-PE" dirty="0"/>
-              <a:t>Diego (aprox. 55 s)
-Lo más importante es que nada revisa la máquina antes de jugar. Estos son tres errores típicos. Un estado al que nunca se llega, porque ninguna transición apunta a él. Una transición hacia un estado que se borró o se renombró. Y un estado del que el personaje no puede salir. Como nada los revisa, se descubren jugando.
-Harel, que propuso los statecharts, ya advertía que los diagramas de estados planos se vuelven difíciles de mantener cuando crecen. Y encontrar estos errores toma tiempo: según Politowski y su equipo, las pruebas de videojuegos dependen casi solo de partidas manuales, y Murphy-Hill encontró que los equipos evitan automatizarlas porque quedan obsoletas cada vez que cambia el diseño.</a:t>
+              <a:t>Diego (aprox. 1 min 20 s)
+¿Por qué es importante? Porque la calidad de un juego es esencial para su éxito y, aun así, según Politowski y su equipo, los videojuegos suelen publicarse con errores desde el primer día, cualquiera que sea su presupuesto o el tamaño del equipo.
+La máquina de estados decide qué puede hacer el personaje en cada momento, así que un error en ella llega directamente al jugador. Estos son tres errores típicos. Si a un estado no llega ninguna transición, el jugador nunca puede usar esa acción. Si una transición apunta a un estado que se borró o se renombró, el personaje no responde al evento. Y si de un estado no se puede salir, el personaje queda atrapado y la partida no avanza. El compilador del juego no detecta ninguno, porque para él las banderas son solo variables.
+Entonces, ¿cómo se encuentran hoy? Jugando, y es un proceso largo: hay que llevar al personaje a cada estado y disparar cada evento. Un personaje con 5 estados y 6 eventos ya tiene 30 combinaciones, y la revisión se repite cada vez que cambia el diseño. Los desarrolladores dependen casi solo de partidas manuales, y Murphy-Hill encontró que evitan automatizarlas porque esas pruebas quedan obsoletas con cada cambio.</a:t>
             </a:r>
             <a:endParaRPr lang="es-PE" dirty="0"/>
           </a:p>
@@ -1391,10 +1392,10 @@
           <a:p>
             <a:r>
               <a:rPr lang="es-PE" dirty="0"/>
-              <a:t>Diego (aprox. 1 min 15 s)
-Buscamos un lenguaje pensado para este caso y no lo encontramos. SCXML, que es una recomendación del W3C, y XState describen máquinas de estados de propósito general: el primero es un formato XML para intérpretes y el segundo, una librería para aplicaciones web.
+              <a:t>Diego (aprox. 1 min 20 s)
+¿Existe algo que resuelva esto? Buscamos y encontramos dos formas de escribir máquinas de estados como texto: SCXML, que es una recomendación del W3C, y XState. Las dos son de propósito general: la primera es un formato XML para intérpretes y la segunda, una librería para aplicaciones web. Ninguna está pensada para describir los personajes de un juego.
 Por eso proponemos PixelLang, un lenguaje de dominio específico. Como explican Mernik y sus coautores, un lenguaje así permite analizar y verificar los programas en los términos del propio dominio.
-Y aquí entra la teoría del curso: cada personaje de PixelLang es un autómata finito A = {Q, Σ, δ, q0, F}. Los estados que declara forman Q, sus eventos son el alfabeto Σ, cada línea "cuando" define una parte de la función de transición δ, el estado inicial es q0 y los estados finales forman F. Entonces el compilador puede comprobar, antes de ejecutar nada, que ese autómata esté bien formado.
+Y aquí entra la teoría del curso: cada personaje de PixelLang es un autómata finito A = {Q, Σ, δ, q0, F}. Los estados que declara forman Q, sus eventos son el alfabeto Σ, cada línea "cuando" define una parte de la función de transición δ, el estado inicial es q0 y los estados finales forman F. Así, el compilador comprueba antes de ejecutar nada que el autómata esté bien formado, y los errores que hoy aparecen jugando aparecen al compilar, con su línea y su columna. Esa es también nuestra motivación: el problema nos permite aplicar directamente lo que vemos en el curso.
 David les cuenta nuestros objetivos.</a:t>
             </a:r>
             <a:endParaRPr lang="es-PE" dirty="0"/>
@@ -14860,7 +14861,7 @@
                   <a:schemeClr val="tx1"/>
                 </a:solidFill>
               </a:rPr>
-              <a:t>Nada la revisa antes de jugar</a:t>
+              <a:t>Un error en la máquina llega al jugador</a:t>
             </a:r>
             <a:endParaRPr lang="es-PE" sz="2800" dirty="0"/>
           </a:p>
@@ -15164,7 +15165,7 @@
                   <a:schemeClr val="tx2"/>
                 </a:solidFill>
               </a:rPr>
-              <a:t>Ninguna transición llega a él.</a:t>
+              <a:t>El jugador nunca puede usar esa acción.</a:t>
             </a:r>
             <a:endParaRPr lang="es-PE" sz="1400" dirty="0"/>
           </a:p>
@@ -15407,7 +15408,7 @@
                   <a:schemeClr val="tx2"/>
                 </a:solidFill>
               </a:rPr>
-              <a:t>La transición apunta a un estado que se borró o se renombró.</a:t>
+              <a:t>El personaje no responde al evento.</a:t>
             </a:r>
             <a:endParaRPr lang="es-PE" sz="1400" dirty="0"/>
           </a:p>
@@ -15650,7 +15651,7 @@
                   <a:schemeClr val="tx2"/>
                 </a:solidFill>
               </a:rPr>
-              <a:t>El personaje entra y se queda atrapado.</a:t>
+              <a:t>El personaje queda atrapado y la partida no avanza.</a:t>
             </a:r>
             <a:endParaRPr lang="es-PE" sz="1400" dirty="0"/>
           </a:p>
@@ -15658,13 +15659,113 @@
       </p:sp>
       <p:sp>
         <p:nvSpPr>
-          <p:cNvPr id="31" name="Pixel"/>
+          <p:cNvPr id="31" name="Combinaciones"/>
           <p:cNvSpPr/>
           <p:nvPr/>
         </p:nvSpPr>
         <p:spPr>
           <a:xfrm>
-            <a:off x="548640" y="5029200"/>
+            <a:off x="548640" y="4846320"/>
+            <a:ext cx="4069080" cy="1143000"/>
+          </a:xfrm>
+          <a:prstGeom prst="rect">
+            <a:avLst/>
+          </a:prstGeom>
+          <a:solidFill>
+            <a:schemeClr val="bg2"/>
+          </a:solidFill>
+          <a:ln w="12700">
+            <a:solidFill>
+              <a:schemeClr val="bg2"/>
+            </a:solidFill>
+            <a:prstDash val="solid"/>
+          </a:ln>
+        </p:spPr>
+      </p:sp>
+      <p:sp>
+        <p:nvSpPr>
+          <p:cNvPr id="32" name="Text 29"/>
+          <p:cNvSpPr txBox="1"/>
+          <p:nvPr/>
+        </p:nvSpPr>
+        <p:spPr>
+          <a:xfrm>
+            <a:off x="731520" y="4846320"/>
+            <a:ext cx="868680" cy="1143000"/>
+          </a:xfrm>
+          <a:prstGeom prst="rect">
+            <a:avLst/>
+          </a:prstGeom>
+          <a:noFill/>
+          <a:ln/>
+        </p:spPr>
+        <p:txBody>
+          <a:bodyPr wrap="square" lIns="0" tIns="0" rIns="0" bIns="0" rtlCol="0" anchor="ctr"/>
+          <a:lstStyle/>
+          <a:p>
+            <a:pPr indent="0" marL="0">
+              <a:buNone/>
+            </a:pPr>
+            <a:r>
+              <a:rPr lang="es-PE" sz="4400" b="1" dirty="0">
+                <a:solidFill>
+                  <a:schemeClr val="accent1"/>
+                </a:solidFill>
+                <a:latin typeface="Consolas" pitchFamily="34" charset="0"/>
+                <a:ea typeface="Consolas" pitchFamily="34" charset="-122"/>
+                <a:cs typeface="Consolas" pitchFamily="34" charset="-120"/>
+              </a:rPr>
+              <a:t>30</a:t>
+            </a:r>
+            <a:endParaRPr lang="es-PE" sz="4400" dirty="0"/>
+          </a:p>
+        </p:txBody>
+      </p:sp>
+      <p:sp>
+        <p:nvSpPr>
+          <p:cNvPr id="33" name="Text 30"/>
+          <p:cNvSpPr txBox="1"/>
+          <p:nvPr/>
+        </p:nvSpPr>
+        <p:spPr>
+          <a:xfrm>
+            <a:off x="1645920" y="4846320"/>
+            <a:ext cx="2834640" cy="1143000"/>
+          </a:xfrm>
+          <a:prstGeom prst="rect">
+            <a:avLst/>
+          </a:prstGeom>
+          <a:noFill/>
+          <a:ln/>
+        </p:spPr>
+        <p:txBody>
+          <a:bodyPr wrap="square" lIns="0" tIns="0" rIns="0" bIns="0" rtlCol="0" anchor="ctr"/>
+          <a:lstStyle/>
+          <a:p>
+            <a:pPr indent="0" marL="0">
+              <a:buNone/>
+            </a:pPr>
+            <a:r>
+              <a:rPr lang="es-PE" sz="1300" dirty="0">
+                <a:solidFill>
+                  <a:schemeClr val="tx1"/>
+                </a:solidFill>
+              </a:rPr>
+              <a:t>combinaciones de estado y evento que se prueban a mano en un personaje con 5 estados y 6 eventos, cada vez que cambia el diseño</a:t>
+            </a:r>
+            <a:endParaRPr lang="es-PE" sz="1300" dirty="0"/>
+          </a:p>
+        </p:txBody>
+      </p:sp>
+      <p:sp>
+        <p:nvSpPr>
+          <p:cNvPr id="34" name="Pixel"/>
+          <p:cNvSpPr/>
+          <p:nvPr/>
+        </p:nvSpPr>
+        <p:spPr>
+          <a:xfrm>
+            <a:off x="4937760" y="4937760"/>
             <a:ext cx="128016" cy="128016"/>
           </a:xfrm>
           <a:prstGeom prst="rect">
@@ -15683,14 +15784,14 @@
       </p:sp>
       <p:sp>
         <p:nvSpPr>
-          <p:cNvPr id="32" name="Text 29"/>
+          <p:cNvPr id="35" name="Text 32"/>
           <p:cNvSpPr txBox="1"/>
           <p:nvPr/>
         </p:nvSpPr>
         <p:spPr>
           <a:xfrm>
-            <a:off x="868680" y="4937760"/>
-            <a:ext cx="10771632" cy="365760"/>
+            <a:off x="5257800" y="4846320"/>
+            <a:ext cx="6382512" cy="502920"/>
           </a:xfrm>
           <a:prstGeom prst="rect">
             <a:avLst/>
@@ -15706,26 +15807,26 @@
               <a:buNone/>
             </a:pPr>
             <a:r>
-              <a:rPr lang="es-PE" sz="1500" dirty="0">
+              <a:rPr lang="es-PE" sz="1400" dirty="0">
                 <a:solidFill>
                   <a:schemeClr val="tx1"/>
                 </a:solidFill>
               </a:rPr>
-              <a:t>Los diagramas de estados planos se vuelven difíciles de mantener a medida que crecen (Harel, 1987).</a:t>
-            </a:r>
-            <a:endParaRPr lang="es-PE" sz="1500" dirty="0"/>
+              <a:t>El compilador del juego no detecta estos errores: para él, las banderas son solo variables.</a:t>
+            </a:r>
+            <a:endParaRPr lang="es-PE" sz="1400" dirty="0"/>
           </a:p>
         </p:txBody>
       </p:sp>
       <p:sp>
         <p:nvSpPr>
-          <p:cNvPr id="33" name="Pixel"/>
+          <p:cNvPr id="36" name="Pixel"/>
           <p:cNvSpPr/>
           <p:nvPr/>
         </p:nvSpPr>
         <p:spPr>
           <a:xfrm>
-            <a:off x="548640" y="5532120"/>
+            <a:off x="4937760" y="5504688"/>
             <a:ext cx="128016" cy="128016"/>
           </a:xfrm>
           <a:prstGeom prst="rect">
@@ -15744,14 +15845,14 @@
       </p:sp>
       <p:sp>
         <p:nvSpPr>
-          <p:cNvPr id="34" name="Text 31"/>
+          <p:cNvPr id="37" name="Text 34"/>
           <p:cNvSpPr txBox="1"/>
           <p:nvPr/>
         </p:nvSpPr>
         <p:spPr>
           <a:xfrm>
-            <a:off x="868680" y="5440680"/>
-            <a:ext cx="10771632" cy="594360"/>
+            <a:off x="5257800" y="5413248"/>
+            <a:ext cx="6382512" cy="777240"/>
           </a:xfrm>
           <a:prstGeom prst="rect">
             <a:avLst/>
@@ -15767,14 +15868,14 @@
               <a:buNone/>
             </a:pPr>
             <a:r>
-              <a:rPr lang="es-PE" sz="1500" dirty="0">
+              <a:rPr lang="es-PE" sz="1400" dirty="0">
                 <a:solidFill>
                   <a:schemeClr val="tx1"/>
                 </a:solidFill>
               </a:rPr>
-              <a:t>Las pruebas dependen casi solo de partidas manuales (Politowski et al., 2021), y los equipos evitan automatizarlas porque quedan obsoletas cuando cambia el diseño (Murphy-Hill et al., 2014).</a:t>
-            </a:r>
-            <a:endParaRPr lang="es-PE" sz="1500" dirty="0"/>
+              <a:t>Hoy se encuentran jugando. Las pruebas son casi solo partidas manuales (Politowski et al., 2021), y los equipos evitan automatizarlas porque quedan obsoletas cuando cambia el diseño (Murphy-Hill et al., 2014).</a:t>
+            </a:r>
+            <a:endParaRPr lang="es-PE" sz="1400" dirty="0"/>
           </a:p>
         </p:txBody>
       </p:sp>
@@ -15954,7 +16055,7 @@
                   <a:schemeClr val="accent5"/>
                 </a:solidFill>
               </a:rPr>
-              <a:t>Formas de escribir máquinas de estados como texto</a:t>
+              <a:t>Lo que existe hoy para escribir máquinas de estados como texto</a:t>
             </a:r>
             <a:endParaRPr lang="es-PE" sz="1200" dirty="0"/>
           </a:p>

</xml_diff>

<commit_message>
Revisión final del informe, la presentación y las pruebas
Informe: redacción más formal en la problemática, regla de E03 con las guardas, columnas contadas desde 0, LETRA y DIGITO definidos, nueva referencia de Unity sobre transiciones, q0 con subíndice, flechas que no se parten, derivaciones de G7 en orden y Apéndice D con la salida real de cada prueba. Presentación: criterios del lexer en el orden de ANTLR, objetivos en infinitivo, comandos con el paso de generar el parser y notas corregidas. correr_pruebas.py muestra los errores léxicos con línea y columna, como el driver.
</commit_message>
<xml_diff>
--- a/docs/PixelLang_Presentacion.pptx
+++ b/docs/PixelLang_Presentacion.pptx
@@ -121,52 +121,52 @@
   <p:extLst>
     <p:ext uri="{521415D9-36F7-43E2-AB2F-B90AF26B5E84}">
       <p14:sectionLst xmlns:p14="http://schemas.microsoft.com/office/powerpoint/2010/main">
-        <p14:section name="Portada" id="{d839d646-af85-8d7f-6229-e31e11e8eb68}">
+        <p14:section name="Portada" id="{272baf8b-337b-ccf7-ecde-4ed2ff2cbe06}">
           <p14:sldIdLst>
             <p14:sldId id="256"/>
           </p14:sldIdLst>
         </p14:section>
-        <p14:section name="Problemática y motivación" id="{6ba6a23c-553e-c975-2319-7e82000be4c0}">
+        <p14:section name="Problemática y motivación" id="{bc6ee13e-bce2-03e6-cda9-47544050b3ea}">
           <p14:sldIdLst>
             <p14:sldId id="257"/>
             <p14:sldId id="258"/>
             <p14:sldId id="259"/>
           </p14:sldIdLst>
         </p14:section>
-        <p14:section name="Objetivos" id="{a2b809c6-d508-9d14-b3bf-8102c2f115d2}">
+        <p14:section name="Objetivos" id="{9c53baf8-e0e3-e727-a2ad-a51a6187311b}">
           <p14:sldIdLst>
             <p14:sldId id="260"/>
           </p14:sldIdLst>
         </p14:section>
-        <p14:section name="Construcciones del lenguaje" id="{fc2e7bb4-2df3-7e09-7c55-2fb5a65f7ff7}">
+        <p14:section name="Construcciones del lenguaje" id="{1d481e8a-6965-f7dc-3238-8d727a728761}">
           <p14:sldIdLst>
             <p14:sldId id="261"/>
             <p14:sldId id="262"/>
           </p14:sldIdLst>
         </p14:section>
-        <p14:section name="Analizador léxico" id="{3ba4e23b-0c1a-9bf8-b467-8b67e57ce9ec}">
+        <p14:section name="Analizador léxico" id="{fe016e7d-7514-1023-bbe8-3b4c871a18cd}">
           <p14:sldIdLst>
             <p14:sldId id="263"/>
           </p14:sldIdLst>
         </p14:section>
-        <p14:section name="Analizador sintáctico" id="{41785f60-74cb-1cdd-e784-496d2fdaa346}">
+        <p14:section name="Analizador sintáctico" id="{11f92795-cf12-a80b-739b-1f7d0171264b}">
           <p14:sldIdLst>
             <p14:sldId id="264"/>
             <p14:sldId id="265"/>
           </p14:sldIdLst>
         </p14:section>
-        <p14:section name="Analizador semántico" id="{3b52b793-6926-a475-42af-5860c6222d44}">
+        <p14:section name="Analizador semántico" id="{89c75175-2c2d-ccaf-e230-8ca604856db3}">
           <p14:sldIdLst>
             <p14:sldId id="266"/>
             <p14:sldId id="267"/>
           </p14:sldIdLst>
         </p14:section>
-        <p14:section name="Repositorio y pruebas" id="{fcee7fce-6978-ba67-25c3-34a9b068c60e}">
+        <p14:section name="Repositorio y pruebas" id="{21cf019b-6015-7fe8-deb4-d1a012765032}">
           <p14:sldIdLst>
             <p14:sldId id="268"/>
           </p14:sldIdLst>
         </p14:section>
-        <p14:section name="Cierre" id="{0c6e6fc4-83d5-1d5e-bc65-ef8c87a6d9b3}">
+        <p14:section name="Cierre" id="{ef01cda7-2491-c1f3-6769-caba1ca7d8d1}">
           <p14:sldIdLst>
             <p14:sldId id="269"/>
             <p14:sldId id="270"/>
@@ -576,9 +576,9 @@
           <a:p>
             <a:r>
               <a:rPr lang="es-PE" dirty="0"/>
-              <a:t>Diego (aprox. 30 s)
+              <a:t>Diego (aprox. 40 s)
 Buenos días, profesor y compañeros. Somos Diego, David, Antony y Mateo, y les presentamos PixelLang, el lenguaje que diseñamos para el trabajo parcial.
-PixelLang sirve para describir cómo se comporta un personaje de un videojuego 2D: en qué estados puede estar y qué lo hace pasar de uno a otro. Yo presento la problemática: cuál es el problema, por qué es importante y qué existe hoy. Luego David presenta los objetivos y las construcciones del lenguaje, Antony el análisis léxico y el sintáctico, y Mateo el análisis semántico y la demostración.</a:t>
+PixelLang sirve para describir cómo se comporta un personaje de un videojuego 2D: en qué estados puede estar y qué lo hace pasar de uno a otro. Yo presento la problemática: cuál es el problema, por qué es importante y qué existe hoy. Luego David presenta los objetivos y las construcciones del lenguaje, Antony el análisis léxico y el sintáctico, y Mateo el análisis semántico, el repositorio con las pruebas y la demostración.</a:t>
             </a:r>
             <a:endParaRPr lang="es-PE" dirty="0"/>
           </a:p>
@@ -666,9 +666,9 @@
           <a:p>
             <a:r>
               <a:rPr lang="es-PE" dirty="0"/>
-              <a:t>Antony (aprox. 55 s)
+              <a:t>Antony (aprox. 45 s)
 Para validar cada gramática derivamos por la izquierda cuatro de sus ejemplos, 28 derivaciones en total, que están en el Apéndice B. Esta es la del ejemplo 5.2, la transición que lleva al personaje a Derrotado.
-Empezamos en transicion y aplicamos su única producción. El no terminal más a la izquierda pasa a ser guarda y, como hay condición, usamos guarda → si expr. Queda expr, que es de la gramática de expresiones; como su subderivación está en esa gramática, aquí la resumimos en un paso con ⇒*, que se lee "deriva en cero o más pasos". Y llegamos a la cadena de tokens del ejemplo.
+Empezamos en transicion y aplicamos su única producción. El no terminal más a la izquierda pasa a ser guarda y, como hay condición, usamos guarda → si expr. Queda expr, que pertenece a la gramática de expresiones, G7; por eso resumimos su subderivación en un solo paso con ⇒*, que se lee "deriva en cero o más pasos". Y llegamos a la cadena de tokens del ejemplo.
 Le paso la palabra a Mateo.</a:t>
             </a:r>
             <a:endParaRPr lang="es-PE" dirty="0"/>
@@ -757,9 +757,9 @@
           <a:p>
             <a:r>
               <a:rPr lang="es-PE" dirty="0"/>
-              <a:t>Mateo (aprox. 1 min)
+              <a:t>Mateo (aprox. 1 min 5 s)
 Gracias, Antony. Que un programa sea sintácticamente correcto no garantiza que su autómata tenga sentido; de eso se encarga el analizador semántico. Como en los laboratorios 4 y 5, es un visitor que recorre el árbol sintáctico que genera ANTLR: al visitar una declaración inserta el símbolo en la tabla, y al visitar un uso lo busca.
-La tabla tiene dos ámbitos: el global, con los personajes, y el de cada personaje. A la derecha está el ámbito de este Caballero, tal como lo imprime la opción --tabla: el atributo vida con su tipo, los tres eventos y los dos estados, con Reposo marcado como inicial. Fíjense que la tabla nos da las partes del autómata: los eventos son Σ, los estados son Q y el inicial es q0; como no hay estados finales, F es vacío.
+La tabla tiene dos niveles de ámbito: el global, con los personajes, y uno por cada personaje. A la derecha está el ámbito de este Caballero, tal como lo imprime la opción --tabla: el atributo vida con su tipo, los tres eventos y los dos estados, con Reposo marcado como inicial. Observen que la tabla contiene las partes del autómata: los eventos son Σ, los estados son Q y el inicial es q0; como no hay estados finales, F es vacío.
 Este programa pasa el análisis léxico y el sintáctico, pero tiene dos errores.</a:t>
             </a:r>
             <a:endParaRPr lang="es-PE" dirty="0"/>
@@ -848,11 +848,11 @@
           <a:p>
             <a:r>
               <a:rPr lang="es-PE" dirty="0"/>
-              <a:t>Mateo (aprox. 50 s)
-Son los dos errores que describimos en el informe, y los dos salen de la definición de autómata.
+              <a:t>Mateo (aprox. 1 min 5 s)
+Son los dos errores que presentamos en el cuerpo del informe, en la Tabla 5, y ambos se derivan de la definición de autómata.
 E01: en la línea 10, Saltando va hacia Volando, que no está en la tabla. La función de transición solo puede llevar a estados de Q.
-E03: en Reposo hay dos transiciones con saltar y ninguna tiene guarda, así que la segunda nunca se toma. Para cada estado y evento, δ tiene un único destino.
-Como pide la clase, cada error indica su código, su línea y su columna, y el análisis no se detiene en el primero: reporta todos juntos. Además de estos dos, el compilador verifica otros ocho, como los estados inalcanzables o los eventos no declarados; están en el Apéndice C.</a:t>
+E03: en Reposo hay dos transiciones con saltar y ninguna tiene guarda, por lo que la segunda nunca se toma. Para cada estado y evento, δ tiene un único destino.
+Como se pidió en clase, cada error indica su código, su línea y su columna, que se cuenta desde cero, como en ANTLR. El análisis no se detiene en el primer error, sino que los reporta todos juntos. Además de estos dos, el compilador verifica otros ocho, como los estados inalcanzables o los eventos no declarados, que están en el Apéndice C. También advierte cuando un estado que no es final no tiene salidas.</a:t>
             </a:r>
             <a:endParaRPr lang="es-PE" dirty="0"/>
           </a:p>
@@ -940,9 +940,9 @@
           <a:p>
             <a:r>
               <a:rPr lang="es-PE" dirty="0"/>
-              <a:t>Mateo (aprox. 55 s)
-Todo está en el repositorio de GitHub. La gramática combinada, PixelLang.g4, contiene el léxico y la sintaxis, y a partir de ella ANTLR4 genera el lexer y el parser. El driver, main.py, ejecuta las etapas en orden: con --tokens muestra los tokens, con --arbol el árbol sintáctico y con --tabla, la tabla de símbolos.
-Probamos cada analizador con entradas válidas e inválidas. Para el léxico, una entrada válida y cinco con caracteres o lexemas que no pertenecen al lenguaje. Para el sintáctico, los 35 ejemplos, que se aceptan, y seis programas con errores, que se rechazan. Y para el semántico, un programa por cada error. Están en el Apéndice D. El avance lo organizamos en GitHub, con un hito por entrega e issues por tarea.</a:t>
+              <a:t>Mateo (aprox. 1 min)
+Todo está en el repositorio de GitHub. La gramática combinada, PixelLang.g4, contiene el léxico y la sintaxis, y a partir de ella ANTLR4 genera el lexer y el parser. El driver, main.py, ejecuta las etapas en orden: con --tokens muestra los tokens; con --arbol, el árbol sintáctico, y con --tabla, la tabla de símbolos.
+Probamos cada analizador con entradas válidas e inválidas. Para el léxico, una entrada válida y cinco con caracteres o lexemas que no pertenecen al lenguaje. Para el sintáctico, los 35 ejemplos, que se aceptan, y seis programas con errores, que se rechazan. Y para el semántico, un programa por cada error, además de los dos ejemplos completos, que no tienen errores. Están en el Apéndice D. El avance lo organizamos en GitHub, con un hito por entrega e issues por tarea.</a:t>
             </a:r>
             <a:endParaRPr lang="es-PE" dirty="0"/>
           </a:p>
@@ -1031,7 +1031,7 @@
             <a:r>
               <a:rPr lang="es-PE" dirty="0"/>
               <a:t>Mateo (aprox. 10 s)
-Estas son las referencias que usamos, en formato APA 7. Son las mismas del informe.</a:t>
+Estas son las referencias que citamos, en formato APA 7; son las mismas que figuran en el informe.</a:t>
             </a:r>
             <a:endParaRPr lang="es-PE" dirty="0"/>
           </a:p>
@@ -1121,7 +1121,7 @@
               <a:rPr lang="es-PE" dirty="0"/>
               <a:t>Mateo (aprox. 10 s, más el video)
 Para terminar, les mostramos el compilador funcionando.
-[Reproducir el video. Al terminar: "Eso es PixelLang. Muchas gracias, quedamos atentos a sus preguntas."]
+[Reproducir el video. Al terminar: "Con esto concluimos la presentación de PixelLang. Muchas gracias; quedamos atentos a sus preguntas."]
 El video está en Google Drive: https://drive.google.com/file/d/1asrzQjXH87vR6JPZDanqDFVFOEntwdZ8/view?usp=sharing. Durante la presentación se abre con un clic en el recuadro o en el enlace de abajo. Para que se reproduzca sin internet, se puede insertar con Insertar &gt; Vídeo &gt; Este dispositivo y ajustarlo al recuadro.</a:t>
             </a:r>
             <a:endParaRPr lang="es-PE" dirty="0"/>
@@ -1210,10 +1210,10 @@
           <a:p>
             <a:r>
               <a:rPr lang="es-PE" dirty="0"/>
-              <a:t>Diego (aprox. 55 s)
+              <a:t>Diego (aprox. 1 min 5 s)
 Empiezo por el problema. En un juego 2D, el comportamiento de un personaje se describe con una máquina de estados finitos: el personaje está en reposo, saltando, atacando o aturdido, y cambia de estado cuando ocurre un evento, como pulsar un botón o recibir un golpe. Así lo explica Nystrom en Game Programming Patterns.
 Sin embargo, esa máquina casi nunca se escribe como tal. En el código queda como lo que ven a la izquierda: condicionales que revisan banderas. Nada impide que atacando y aturdido queden activas a la vez, y para saber qué estados existen hay que leer todo el bucle.
-En los editores visuales, como el de Unity, los estados sí se dibujan como nodos, pero las condiciones de cada transición quedan en paneles separados. La máquina existe en el diseño, pero no queda escrita en ninguna parte.</a:t>
+En los editores visuales, como el de Unity, los estados sí se dibujan como nodos, pero las condiciones de cada transición se configuran aparte, en el Inspector. Además, como advertía Harel, un diagrama de estados plano se vuelve difícil de mantener a medida que crece.</a:t>
             </a:r>
             <a:endParaRPr lang="es-PE" dirty="0"/>
           </a:p>
@@ -1301,10 +1301,10 @@
           <a:p>
             <a:r>
               <a:rPr lang="es-PE" dirty="0"/>
-              <a:t>Diego (aprox. 1 min 20 s)
-¿Por qué es importante? Porque la calidad de un juego es esencial para su éxito y, aun así, según Politowski y su equipo, los videojuegos suelen publicarse con errores desde el primer día, cualquiera que sea su presupuesto o el tamaño del equipo.
-La máquina de estados decide qué puede hacer el personaje en cada momento, así que un error en ella llega directamente al jugador. Estos son tres errores típicos. Si a un estado no llega ninguna transición, el jugador nunca puede usar esa acción. Si una transición apunta a un estado que se borró o se renombró, el personaje no responde al evento. Y si de un estado no se puede salir, el personaje queda atrapado y la partida no avanza. El compilador del juego no detecta ninguno, porque para él las banderas son solo variables.
-Entonces, ¿cómo se encuentran hoy? Jugando, y es un proceso largo: hay que llevar al personaje a cada estado y disparar cada evento. Un personaje con 5 estados y 6 eventos ya tiene 30 combinaciones, y la revisión se repite cada vez que cambia el diseño. Los desarrolladores dependen casi solo de partidas manuales, y Murphy-Hill encontró que evitan automatizarlas porque esas pruebas quedan obsoletas con cada cambio.</a:t>
+              <a:t>Diego (aprox. 1 min 35 s)
+¿Por qué es importante? Porque la calidad de un juego es esencial para su éxito y, aun así, según Politowski y sus coautores, los videojuegos suelen publicarse con errores desde el primer día, cualquiera que sea su presupuesto o el tamaño del equipo.
+La máquina de estados decide qué puede hacer el personaje en cada momento, por lo que un error en ella llega directamente al jugador. Estos son tres errores típicos. Si a un estado no se puede llegar desde el estado inicial, el jugador nunca puede usar esa acción. Si una transición apunta a un estado que se borró o se renombró, el personaje no responde al evento. Y si de un estado no se puede salir, el personaje queda atrapado y la partida no avanza. El compilador del juego no detecta ninguno, porque para él las banderas son solo variables.
+Entonces, ¿cómo se detectan hoy estos errores? Jugando, y es un proceso largo: hay que llevar al personaje a cada estado y disparar cada evento. Un personaje con 5 estados y 6 eventos ya tiene 30 combinaciones, y la revisión se repite cada vez que cambia el diseño. Los desarrolladores dependen casi exclusivamente de las partidas manuales, y Murphy-Hill y sus coautores encontraron que evitan las pruebas automatizadas porque quedan obsoletas con cada cambio del diseño.</a:t>
             </a:r>
             <a:endParaRPr lang="es-PE" dirty="0"/>
           </a:p>
@@ -1392,11 +1392,11 @@
           <a:p>
             <a:r>
               <a:rPr lang="es-PE" dirty="0"/>
-              <a:t>Diego (aprox. 1 min 20 s)
-¿Existe algo que resuelva esto? Buscamos y encontramos dos formas de escribir máquinas de estados como texto: SCXML, que es una recomendación del W3C, y XState. Las dos son de propósito general: la primera es un formato XML para intérpretes y la segunda, una librería para aplicaciones web. Ninguna está pensada para describir los personajes de un juego.
+              <a:t>Diego (aprox. 1 min 25 s)
+¿Existe algo que resuelva esto? Entre las herramientas que existen para escribir máquinas de estados como texto, revisamos dos representativas: SCXML, que es una recomendación del W3C, y XState. Las dos son de propósito general: la primera es un formato XML para intérpretes y la segunda, una biblioteca para aplicaciones web. Ninguna está pensada para describir los personajes de un juego.
 Por eso proponemos PixelLang, un lenguaje de dominio específico. Como explican Mernik y sus coautores, un lenguaje así permite analizar y verificar los programas en los términos del propio dominio.
-Y aquí entra la teoría del curso: cada personaje de PixelLang es un autómata finito A = {Q, Σ, δ, q0, F}. Los estados que declara forman Q, sus eventos son el alfabeto Σ, cada línea "cuando" define una parte de la función de transición δ, el estado inicial es q0 y los estados finales forman F. Así, el compilador comprueba antes de ejecutar nada que el autómata esté bien formado, y los errores que hoy aparecen jugando aparecen al compilar, con su línea y su columna. Esa es también nuestra motivación: el problema nos permite aplicar directamente lo que vemos en el curso.
-David les cuenta nuestros objetivos.</a:t>
+Aquí aplicamos la teoría del curso: cada personaje de PixelLang es un autómata finito A = {Q, Σ, δ, q0, F}. Los estados que declara forman Q, sus eventos son el alfabeto Σ, cada línea "cuando" define una parte de la función de transición δ, el estado inicial es q0 y los estados finales forman F. Así, el compilador comprueba, antes de ejecutar nada, que el autómata esté bien formado, y los errores que hoy se descubren jugando se detectan al compilar, con su línea y su columna. Esto también nos motiva, porque el problema permite aplicar directamente lo que vemos en el curso.
+A continuación, David presentará los objetivos.</a:t>
             </a:r>
             <a:endParaRPr lang="es-PE" dirty="0"/>
           </a:p>
@@ -1486,7 +1486,7 @@
               <a:rPr lang="es-PE" dirty="0"/>
               <a:t>David (aprox. 50 s)
 Gracias, Diego. Nuestro objetivo general es desarrollar un compilador para PixelLang que verifique, al compilar, que la máquina de estados de cada personaje esté bien formada, y que la traduzca a código ejecutable.
-Para lograrlo nos planteamos cuatro objetivos, uno por etapa del compilador: definir el léxico e implementar el analizador léxico con expresiones regulares en ANTLR4; diseñar una gramática libre de contexto por construcción, validarla con derivaciones más a la izquierda e implementar el parser; construir la tabla de símbolos y el analizador semántico que detecta los errores del autómata; y generar código con LLVM. Los tres primeros son los de este trabajo; la generación de código corresponde al hito 3.</a:t>
+Para lograrlo nos planteamos cuatro objetivos, uno por etapa del compilador: definir el léxico e implementar el analizador léxico con expresiones regulares en ANTLR4; diseñar una gramática libre de contexto por construcción, validarla con derivaciones más a la izquierda e implementar el parser; construir la tabla de símbolos y el analizador semántico que detecta los errores del autómata; y generar código con LLVM. Los tres primeros forman parte de este trabajo; la generación de código corresponde al hito 3.</a:t>
             </a:r>
             <a:endParaRPr lang="es-PE" dirty="0"/>
           </a:p>
@@ -1576,7 +1576,7 @@
               <a:rPr lang="es-PE" dirty="0"/>
               <a:t>David (aprox. 1 min)
 Veamos cómo se escribe un programa. PixelLang tiene siete construcciones, y de cada una les mostramos un ejemplo.
-La primera es el programa con la declaración de personaje. Un programa declara uno o más personajes y, al final, cero o más simulaciones. Este es el personaje más simple que tenemos, una puerta: un evento, ser_abierta; un estado inicial, Cerrada, y un estado final, Abierta. La última línea es una simulación: le da a la puerta una secuencia de eventos.
+La primera es el programa con la declaración de personaje. Un programa declara uno o más personajes y, al final, cero o más simulaciones. Este es el ejemplo 1.2, una puerta: un evento, ser_abierta; un estado inicial, Cerrada, y un estado final, Abierta. La última línea es una simulación: le da a la puerta una secuencia de eventos. En este hito, el compilador verifica que el personaje y los eventos de la simulación existan.
 Dentro de cada personaje van, en este orden, los atributos, los eventos y los estados. Un atributo tiene nombre, tipo y valor inicial: vida es un entero que empieza en 100. Y la declaración de eventos lista los eventos del personaje, que forman su alfabeto.</a:t>
             </a:r>
             <a:endParaRPr lang="es-PE" dirty="0"/>
@@ -1665,11 +1665,11 @@
           <a:p>
             <a:r>
               <a:rPr lang="es-PE" dirty="0"/>
-              <a:t>David (aprox. 55 s)
+              <a:t>David (aprox. 50 s)
 Un estado puede llevar el modificador inicial o final, acciones al entrar y sus transiciones. Aquí, al entrar a Saltando, el personaje sube 2.5, y sale de ese estado al aterrizar o al recibir un golpe.
 Una transición indica el evento que la dispara, una guarda opcional con si y el estado destino: si al terminar el aturdimiento la vida llegó a cero, el personaje pasa a Derrotado.
 Las acciones son asignaciones y selecciones con si y un sino opcional. Y las expresiones combinan operadores lógicos, relacionales y aritméticos.
-Cada construcción tiene cinco ejemplos, 35 en total; están en el Apéndice A del informe y el parser los acepta todos. Antony les explica cómo se reconocen.</a:t>
+Cada construcción tiene cinco ejemplos, 35 en total; están en el Apéndice A del informe y el parser los acepta todos. A continuación, Antony explicará cómo se reconocen estas construcciones.</a:t>
             </a:r>
             <a:endParaRPr lang="es-PE" dirty="0"/>
           </a:p>
@@ -1758,9 +1758,9 @@
             <a:r>
               <a:rPr lang="es-PE" dirty="0"/>
               <a:t>Antony (aprox. 1 min 5 s)
-Gracias, David. La primera etapa es el analizador léxico, que implementamos con expresiones regulares en ANTLR4. PixelLang tiene 43 tokens: diez palabras reservadas, cinco para los tipos y los valores lógicos, quince operadores, siete signos de puntuación, y los números enteros, los reales y los identificadores. Los comentarios y los espacios se reconocen, pero se descartan.
+Gracias, David. La primera etapa es el analizador léxico, que implementamos con expresiones regulares en ANTLR4. PixelLang tiene 43 tokens: diez palabras reservadas, cinco para los tipos y los valores lógicos, quince operadores, siete signos de puntuación, tres para los números enteros, los reales y los identificadores, y tres para los comentarios y los espacios, que se reconocen pero se descartan.
 En el informe el léxico está en la forma token: lista de lexemas; aquí ven un extracto y, abajo, dos líneas de entrada con sus tokens. El comentario no produce ninguno.
-Los conflictos se resuelven con dos criterios. A igual longitud gana la regla que aparece primero; por eso las palabras reservadas van antes que ID, y "si" es la palabra reservada SI. Y siempre gana el lexema más largo: "siguiente" es un identificador y "&lt;=" es un solo token.</a:t>
+Los conflictos se resuelven con dos criterios. Primero, siempre gana el lexema más largo; por eso "siguiente" es un identificador y "&lt;=" es un solo token. Segundo, si dos reglas reconocen un lexema de la misma longitud, gana la que aparece primero; por eso las palabras reservadas van antes que ID, y "si" es la palabra reservada SI.</a:t>
             </a:r>
             <a:endParaRPr lang="es-PE" dirty="0"/>
           </a:p>
@@ -1848,10 +1848,10 @@
           <a:p>
             <a:r>
               <a:rPr lang="es-PE" dirty="0"/>
-              <a:t>Antony (aprox. 1 min 10 s)
+              <a:t>Antony (aprox. 1 min 5 s)
 Para el análisis sintáctico escribimos siete gramáticas libres de contexto, una por construcción, con la notación de clase: los no terminales en cursiva, los terminales en negrita, las alternativas separadas con una barra y ε para la cadena vacía. Los terminales id, num y dec representan los tokens ID, NUM_ENTERO y NUM_REAL.
 A la izquierda está la de transiciones: cuando, el evento, una guarda opcional, la flecha, el destino y el punto y coma; la guarda es si seguido de una expresión, o la cadena vacía. Debajo está la de eventos, que muestra cómo escribimos las listas: con recursión por la izquierda.
-A la derecha está la de expresiones. Sigue el esquema de expr, term y factor que vimos en clase, con un no terminal por nivel de precedencia, desde el o lógico hasta el factor. Así cada expresión tiene un solo árbol y la gramática no es ambigua.</a:t>
+A la derecha está la de expresiones. Sigue el esquema de expr, term y factor que vimos en clase, con un no terminal por nivel de precedencia, desde el o lógico hasta el factor. Así, cada expresión tiene un solo árbol de derivación y la gramática no es ambigua.</a:t>
             </a:r>
             <a:endParaRPr lang="es-PE" dirty="0"/>
           </a:p>
@@ -10526,7 +10526,18 @@
                 <a:ea typeface="Consolas" pitchFamily="34" charset="-122"/>
                 <a:cs typeface="Consolas" pitchFamily="34" charset="-120"/>
               </a:rPr>
-              <a:t>q0</a:t>
+              <a:t>q</a:t>
+            </a:r>
+            <a:r>
+              <a:rPr lang="es-PE" sz="1800" b="1" baseline="-40000" dirty="0">
+                <a:solidFill>
+                  <a:schemeClr val="accent1"/>
+                </a:solidFill>
+                <a:latin typeface="Consolas" pitchFamily="34" charset="0"/>
+                <a:ea typeface="Consolas" pitchFamily="34" charset="-122"/>
+                <a:cs typeface="Consolas" pitchFamily="34" charset="-120"/>
+              </a:rPr>
+              <a:t>0</a:t>
             </a:r>
             <a:r>
               <a:rPr lang="es-PE" sz="1600" dirty="0">
@@ -12367,7 +12378,7 @@
         <p:spPr>
           <a:xfrm>
             <a:off x="548640" y="4041648"/>
-            <a:ext cx="5669280" cy="987552"/>
+            <a:ext cx="5669280" cy="1188720"/>
           </a:xfrm>
           <a:prstGeom prst="rect">
             <a:avLst/>
@@ -12380,6 +12391,26 @@
         <p:txBody>
           <a:bodyPr wrap="square" lIns="127000" tIns="101600" rIns="127000" bIns="101600" rtlCol="0" anchor="t"/>
           <a:lstStyle/>
+          <a:p>
+            <a:pPr indent="0" marL="0">
+              <a:lnSpc>
+                <a:spcPct val="100000"/>
+              </a:lnSpc>
+              <a:buNone/>
+            </a:pPr>
+            <a:r>
+              <a:rPr lang="es-PE" sz="1250" dirty="0">
+                <a:solidFill>
+                  <a:schemeClr val="accent5"/>
+                </a:solidFill>
+                <a:latin typeface="Consolas" pitchFamily="34" charset="0"/>
+                <a:ea typeface="Consolas" pitchFamily="34" charset="-122"/>
+                <a:cs typeface="Consolas" pitchFamily="34" charset="-120"/>
+              </a:rPr>
+              <a:t># antes: generar el parser con ANTLR4 (Ctrl+Shift+B)</a:t>
+            </a:r>
+            <a:endParaRPr lang="es-PE" sz="1250" dirty="0"/>
+          </a:p>
           <a:p>
             <a:pPr indent="0" marL="0">
               <a:lnSpc>
@@ -12858,7 +12889,7 @@
                   <a:schemeClr val="tx2"/>
                 </a:solidFill>
               </a:rPr>
-              <a:t>35 ejemplos aceptados y 6 programas con errores rechazados</a:t>
+              <a:t>35 ejemplos aceptados y 6 programas erróneos rechazados</a:t>
             </a:r>
             <a:endParaRPr lang="es-PE" sz="1400" dirty="0"/>
           </a:p>
@@ -13506,7 +13537,7 @@
                   <a:schemeClr val="tx1"/>
                 </a:solidFill>
               </a:rPr>
-              <a:t>Introduction to Animator Controllers</a:t>
+              <a:t>Animation transitions</a:t>
             </a:r>
             <a:r>
               <a:rPr lang="es-PE" sz="1200" dirty="0">
@@ -13514,7 +13545,7 @@
                   <a:schemeClr val="tx1"/>
                 </a:solidFill>
               </a:rPr>
-              <a:t>. Recuperado el 4 de octubre de 2026, de https://docs.unity3d.com/Manual/class-AnimatorController.html</a:t>
+              <a:t>. Recuperado el 6 de octubre de 2026, de https://docs.unity3d.com/Manual/class-Transition.html</a:t>
             </a:r>
             <a:endParaRPr lang="es-PE" sz="1200" dirty="0"/>
           </a:p>
@@ -14317,6 +14348,14 @@
               <a:buNone/>
             </a:pPr>
             <a:r>
+              <a:rPr lang="es-PE" sz="1500" dirty="0">
+                <a:solidFill>
+                  <a:schemeClr val="tx1"/>
+                </a:solidFill>
+              </a:rPr>
+              <a:t>Nada impide que </a:t>
+            </a:r>
+            <a:r>
               <a:rPr lang="es-PE" sz="1500" b="1" dirty="0">
                 <a:solidFill>
                   <a:schemeClr val="accent1"/>
@@ -14352,7 +14391,7 @@
                   <a:schemeClr val="tx1"/>
                 </a:solidFill>
               </a:rPr>
-              <a:t> pueden quedar en true a la vez: nada lo impide.</a:t>
+              <a:t> valgan true al mismo tiempo.</a:t>
             </a:r>
             <a:endParaRPr lang="es-PE" sz="1500" dirty="0"/>
           </a:p>
@@ -14473,7 +14512,7 @@
                   <a:schemeClr val="tx2"/>
                 </a:solidFill>
               </a:rPr>
-              <a:t>Reposo, saltando, atacando o aturdido: el personaje cambia de estado con cada evento (Nystrom, 2014).</a:t>
+              <a:t>Reposo, saltando, atacando o aturdido: el personaje cambia de estado cuando ocurre un evento (Nystrom, 2014).</a:t>
             </a:r>
             <a:endParaRPr lang="es-PE" sz="1500" dirty="0"/>
           </a:p>
@@ -14679,7 +14718,7 @@
                   <a:schemeClr val="tx1"/>
                 </a:solidFill>
               </a:rPr>
-              <a:t>Los editores no la ordenan</a:t>
+              <a:t>En los editores queda repartida</a:t>
             </a:r>
             <a:endParaRPr lang="es-PE" sz="1800" dirty="0"/>
           </a:p>
@@ -14715,7 +14754,7 @@
                   <a:schemeClr val="tx2"/>
                 </a:solidFill>
               </a:rPr>
-              <a:t>En Unity los estados son nodos, pero las condiciones de cada transición quedan en paneles separados (Unity Technologies, s. f.).</a:t>
+              <a:t>En Unity los estados son nodos, pero las condiciones de cada transición se configuran aparte, en el Inspector (Unity Technologies, s. f.).</a:t>
             </a:r>
             <a:endParaRPr lang="es-PE" sz="1500" dirty="0"/>
           </a:p>
@@ -15873,7 +15912,7 @@
                   <a:schemeClr val="tx1"/>
                 </a:solidFill>
               </a:rPr>
-              <a:t>Hoy se encuentran jugando. Las pruebas son casi solo partidas manuales (Politowski et al., 2021), y los equipos evitan automatizarlas porque quedan obsoletas cuando cambia el diseño (Murphy-Hill et al., 2014).</a:t>
+              <a:t>Hoy estos errores se detectan jugando. Las pruebas son casi exclusivamente partidas manuales (Politowski et al., 2021), y los equipos evitan las pruebas automatizadas porque quedan obsoletas cuando cambia el diseño (Murphy-Hill et al., 2014).</a:t>
             </a:r>
             <a:endParaRPr lang="es-PE" sz="1400" dirty="0"/>
           </a:p>
@@ -16055,7 +16094,7 @@
                   <a:schemeClr val="accent5"/>
                 </a:solidFill>
               </a:rPr>
-              <a:t>Lo que existe hoy para escribir máquinas de estados como texto</a:t>
+              <a:t>Alternativas actuales frente a PixelLang</a:t>
             </a:r>
             <a:endParaRPr lang="es-PE" sz="1200" dirty="0"/>
           </a:p>
@@ -16255,7 +16294,7 @@
                   <a:schemeClr val="tx2"/>
                 </a:solidFill>
               </a:rPr>
-              <a:t>Librería de propósito general para aplicaciones web (Stately, s. f.)</a:t>
+              <a:t>Biblioteca de propósito general para aplicaciones web (Stately, s. f.)</a:t>
             </a:r>
             <a:endParaRPr lang="es-PE" sz="1400" dirty="0"/>
           </a:p>
@@ -17164,7 +17203,7 @@
                             <a:schemeClr val="accent1"/>
                           </a:solidFill>
                         </a:rPr>
-                        <a:t>q0</a:t>
+                        <a:t>q₀</a:t>
                       </a:r>
                       <a:endParaRPr lang="es-PE" sz="1700" dirty="0"/>
                     </a:p>
@@ -17570,7 +17609,29 @@
                 <a:ea typeface="Consolas" pitchFamily="34" charset="-122"/>
                 <a:cs typeface="Consolas" pitchFamily="34" charset="-120"/>
               </a:rPr>
-              <a:t>A = {Q, Σ, δ, q0, F}</a:t>
+              <a:t>A = {Q, Σ, δ, q</a:t>
+            </a:r>
+            <a:r>
+              <a:rPr lang="es-PE" sz="2400" b="1" baseline="-40000" dirty="0">
+                <a:solidFill>
+                  <a:schemeClr val="accent1"/>
+                </a:solidFill>
+                <a:latin typeface="Consolas" pitchFamily="34" charset="0"/>
+                <a:ea typeface="Consolas" pitchFamily="34" charset="-122"/>
+                <a:cs typeface="Consolas" pitchFamily="34" charset="-120"/>
+              </a:rPr>
+              <a:t>0</a:t>
+            </a:r>
+            <a:r>
+              <a:rPr lang="es-PE" sz="2400" b="1" dirty="0">
+                <a:solidFill>
+                  <a:schemeClr val="accent1"/>
+                </a:solidFill>
+                <a:latin typeface="Consolas" pitchFamily="34" charset="0"/>
+                <a:ea typeface="Consolas" pitchFamily="34" charset="-122"/>
+                <a:cs typeface="Consolas" pitchFamily="34" charset="-120"/>
+              </a:rPr>
+              <a:t>, F}</a:t>
             </a:r>
             <a:endParaRPr lang="es-PE" sz="2400" dirty="0"/>
           </a:p>
@@ -17642,7 +17703,7 @@
                   <a:schemeClr val="tx1"/>
                 </a:solidFill>
               </a:rPr>
-              <a:t>Verificar al personaje es verificar que su autómata esté bien formado.</a:t>
+              <a:t>El compilador verifica que el autómata de cada personaje esté bien formado.</a:t>
             </a:r>
             <a:endParaRPr lang="es-PE" sz="1700" dirty="0"/>
           </a:p>
@@ -18196,7 +18257,7 @@
                   <a:schemeClr val="tx2"/>
                 </a:solidFill>
               </a:rPr>
-              <a:t>Una GLC por construcción, validada con derivaciones, y el parser en ANTLR4</a:t>
+              <a:t>Diseñar una GLC por construcción, validarla con derivaciones e implementar el parser en ANTLR4</a:t>
             </a:r>
             <a:endParaRPr lang="es-PE" sz="1400" dirty="0"/>
           </a:p>
@@ -18358,7 +18419,7 @@
                   <a:schemeClr val="tx2"/>
                 </a:solidFill>
               </a:rPr>
-              <a:t>Tabla de símbolos por personaje y detección de los errores del autómata</a:t>
+              <a:t>Construir la tabla de símbolos por personaje y detectar los errores del autómata</a:t>
             </a:r>
             <a:endParaRPr lang="es-PE" sz="1400" dirty="0"/>
           </a:p>
@@ -22625,7 +22686,7 @@
                   <a:schemeClr val="tx1"/>
                 </a:solidFill>
               </a:rPr>
-              <a:t>A igual longitud, gana la primera regla</a:t>
+              <a:t>Siempre gana el lexema más largo</a:t>
             </a:r>
             <a:endParaRPr lang="es-PE" sz="1500" dirty="0"/>
           </a:p>
@@ -22661,7 +22722,7 @@
                   <a:schemeClr val="tx2"/>
                 </a:solidFill>
               </a:rPr>
-              <a:t>Por eso las palabras reservadas van antes que ID.</a:t>
+              <a:t>Por eso siguiente es un ID y &lt;= es un solo token.</a:t>
             </a:r>
             <a:endParaRPr lang="es-PE" sz="1400" dirty="0"/>
           </a:p>
@@ -22763,7 +22824,7 @@
                   <a:schemeClr val="tx1"/>
                 </a:solidFill>
               </a:rPr>
-              <a:t>Siempre gana el lexema más largo</a:t>
+              <a:t>A igual longitud, gana la primera regla</a:t>
             </a:r>
             <a:endParaRPr lang="es-PE" sz="1500" dirty="0"/>
           </a:p>
@@ -22799,7 +22860,7 @@
                   <a:schemeClr val="tx2"/>
                 </a:solidFill>
               </a:rPr>
-              <a:t>siguiente es un ID y &lt;= es un solo token.</a:t>
+              <a:t>Por eso las palabras reservadas van antes que ID.</a:t>
             </a:r>
             <a:endParaRPr lang="es-PE" sz="1400" dirty="0"/>
           </a:p>

</xml_diff>